<commit_message>
Improved font in ComponentManager figure (docs)
</commit_message>
<xml_diff>
--- a/docs/libraries/cisstMultiTask/images/ComponentManager.pptx
+++ b/docs/libraries/cisstMultiTask/images/ComponentManager.pptx
@@ -104,6 +104,11 @@
       </a:defRPr>
     </a:lvl9pPr>
   </p:defaultTextStyle>
+  <p:extLst>
+    <p:ext uri="{EFAFB233-063F-42B5-8137-9DF3F51BA10A}">
+      <p15:sldGuideLst xmlns:p15="http://schemas.microsoft.com/office/powerpoint/2012/main"/>
+    </p:ext>
+  </p:extLst>
 </p:presentation>
 </file>
 
@@ -254,7 +259,7 @@
           <a:p>
             <a:fld id="{EA81B8F4-F78A-4F9C-868F-65AE236911CC}" type="datetimeFigureOut">
               <a:rPr lang="en-US" smtClean="0"/>
-              <a:t>7/9/2026</a:t>
+              <a:t>7/10/2026</a:t>
             </a:fld>
             <a:endParaRPr lang="en-US"/>
           </a:p>
@@ -452,7 +457,7 @@
           <a:p>
             <a:fld id="{EA81B8F4-F78A-4F9C-868F-65AE236911CC}" type="datetimeFigureOut">
               <a:rPr lang="en-US" smtClean="0"/>
-              <a:t>7/9/2026</a:t>
+              <a:t>7/10/2026</a:t>
             </a:fld>
             <a:endParaRPr lang="en-US"/>
           </a:p>
@@ -660,7 +665,7 @@
           <a:p>
             <a:fld id="{EA81B8F4-F78A-4F9C-868F-65AE236911CC}" type="datetimeFigureOut">
               <a:rPr lang="en-US" smtClean="0"/>
-              <a:t>7/9/2026</a:t>
+              <a:t>7/10/2026</a:t>
             </a:fld>
             <a:endParaRPr lang="en-US"/>
           </a:p>
@@ -858,7 +863,7 @@
           <a:p>
             <a:fld id="{EA81B8F4-F78A-4F9C-868F-65AE236911CC}" type="datetimeFigureOut">
               <a:rPr lang="en-US" smtClean="0"/>
-              <a:t>7/9/2026</a:t>
+              <a:t>7/10/2026</a:t>
             </a:fld>
             <a:endParaRPr lang="en-US"/>
           </a:p>
@@ -1133,7 +1138,7 @@
           <a:p>
             <a:fld id="{EA81B8F4-F78A-4F9C-868F-65AE236911CC}" type="datetimeFigureOut">
               <a:rPr lang="en-US" smtClean="0"/>
-              <a:t>7/9/2026</a:t>
+              <a:t>7/10/2026</a:t>
             </a:fld>
             <a:endParaRPr lang="en-US"/>
           </a:p>
@@ -1398,7 +1403,7 @@
           <a:p>
             <a:fld id="{EA81B8F4-F78A-4F9C-868F-65AE236911CC}" type="datetimeFigureOut">
               <a:rPr lang="en-US" smtClean="0"/>
-              <a:t>7/9/2026</a:t>
+              <a:t>7/10/2026</a:t>
             </a:fld>
             <a:endParaRPr lang="en-US"/>
           </a:p>
@@ -1810,7 +1815,7 @@
           <a:p>
             <a:fld id="{EA81B8F4-F78A-4F9C-868F-65AE236911CC}" type="datetimeFigureOut">
               <a:rPr lang="en-US" smtClean="0"/>
-              <a:t>7/9/2026</a:t>
+              <a:t>7/10/2026</a:t>
             </a:fld>
             <a:endParaRPr lang="en-US"/>
           </a:p>
@@ -1951,7 +1956,7 @@
           <a:p>
             <a:fld id="{EA81B8F4-F78A-4F9C-868F-65AE236911CC}" type="datetimeFigureOut">
               <a:rPr lang="en-US" smtClean="0"/>
-              <a:t>7/9/2026</a:t>
+              <a:t>7/10/2026</a:t>
             </a:fld>
             <a:endParaRPr lang="en-US"/>
           </a:p>
@@ -2064,7 +2069,7 @@
           <a:p>
             <a:fld id="{EA81B8F4-F78A-4F9C-868F-65AE236911CC}" type="datetimeFigureOut">
               <a:rPr lang="en-US" smtClean="0"/>
-              <a:t>7/9/2026</a:t>
+              <a:t>7/10/2026</a:t>
             </a:fld>
             <a:endParaRPr lang="en-US"/>
           </a:p>
@@ -2375,7 +2380,7 @@
           <a:p>
             <a:fld id="{EA81B8F4-F78A-4F9C-868F-65AE236911CC}" type="datetimeFigureOut">
               <a:rPr lang="en-US" smtClean="0"/>
-              <a:t>7/9/2026</a:t>
+              <a:t>7/10/2026</a:t>
             </a:fld>
             <a:endParaRPr lang="en-US"/>
           </a:p>
@@ -2663,7 +2668,7 @@
           <a:p>
             <a:fld id="{EA81B8F4-F78A-4F9C-868F-65AE236911CC}" type="datetimeFigureOut">
               <a:rPr lang="en-US" smtClean="0"/>
-              <a:t>7/9/2026</a:t>
+              <a:t>7/10/2026</a:t>
             </a:fld>
             <a:endParaRPr lang="en-US"/>
           </a:p>
@@ -2904,7 +2909,7 @@
           <a:p>
             <a:fld id="{EA81B8F4-F78A-4F9C-868F-65AE236911CC}" type="datetimeFigureOut">
               <a:rPr lang="en-US" smtClean="0"/>
-              <a:t>7/9/2026</a:t>
+              <a:t>7/10/2026</a:t>
             </a:fld>
             <a:endParaRPr lang="en-US"/>
           </a:p>
@@ -3372,41 +3377,65 @@
           <a:p>
             <a:pPr algn="ctr"/>
             <a:r>
-              <a:rPr lang="en-US" sz="1600" b="1" dirty="0"/>
+              <a:rPr lang="en-US" sz="1600" b="1" dirty="0">
+                <a:latin typeface="Arial" panose="020B0604020202020204" pitchFamily="34" charset="0"/>
+                <a:cs typeface="Arial" panose="020B0604020202020204" pitchFamily="34" charset="0"/>
+              </a:rPr>
               <a:t>Manager Component</a:t>
             </a:r>
           </a:p>
           <a:p>
             <a:pPr algn="ctr"/>
             <a:r>
-              <a:rPr lang="en-US" sz="1600" b="1" dirty="0"/>
+              <a:rPr lang="en-US" sz="1600" b="1" dirty="0">
+                <a:latin typeface="Arial" panose="020B0604020202020204" pitchFamily="34" charset="0"/>
+                <a:cs typeface="Arial" panose="020B0604020202020204" pitchFamily="34" charset="0"/>
+              </a:rPr>
               <a:t>“MCS”</a:t>
             </a:r>
           </a:p>
           <a:p>
             <a:pPr algn="ctr"/>
-            <a:endParaRPr lang="en-US" sz="1600" dirty="0"/>
+            <a:endParaRPr lang="en-US" sz="1600" dirty="0">
+              <a:latin typeface="Arial" panose="020B0604020202020204" pitchFamily="34" charset="0"/>
+              <a:cs typeface="Arial" panose="020B0604020202020204" pitchFamily="34" charset="0"/>
+            </a:endParaRPr>
           </a:p>
           <a:p>
             <a:pPr algn="ctr"/>
             <a:r>
-              <a:rPr lang="en-US" sz="1400" dirty="0" err="1"/>
+              <a:rPr lang="en-US" sz="1400" dirty="0" err="1">
+                <a:latin typeface="Arial" panose="020B0604020202020204" pitchFamily="34" charset="0"/>
+                <a:cs typeface="Arial" panose="020B0604020202020204" pitchFamily="34" charset="0"/>
+              </a:rPr>
               <a:t>mtsManagerComponent</a:t>
             </a:r>
-            <a:endParaRPr lang="en-US" sz="1400" dirty="0"/>
+            <a:endParaRPr lang="en-US" sz="1400" dirty="0">
+              <a:latin typeface="Arial" panose="020B0604020202020204" pitchFamily="34" charset="0"/>
+              <a:cs typeface="Arial" panose="020B0604020202020204" pitchFamily="34" charset="0"/>
+            </a:endParaRPr>
           </a:p>
           <a:p>
             <a:pPr algn="ctr"/>
             <a:r>
-              <a:rPr lang="en-US" sz="1400" dirty="0"/>
+              <a:rPr lang="en-US" sz="1400" dirty="0">
+                <a:latin typeface="Arial" panose="020B0604020202020204" pitchFamily="34" charset="0"/>
+                <a:cs typeface="Arial" panose="020B0604020202020204" pitchFamily="34" charset="0"/>
+              </a:rPr>
               <a:t>(</a:t>
             </a:r>
             <a:r>
-              <a:rPr lang="en-US" sz="1400" dirty="0" err="1"/>
+              <a:rPr lang="en-US" sz="1400" dirty="0" err="1">
+                <a:latin typeface="Arial" panose="020B0604020202020204" pitchFamily="34" charset="0"/>
+                <a:cs typeface="Arial" panose="020B0604020202020204" pitchFamily="34" charset="0"/>
+              </a:rPr>
               <a:t>mtsTaskFromSignal</a:t>
             </a:r>
             <a:r>
-              <a:rPr lang="en-US" sz="1400" dirty="0"/>
+              <a:rPr lang="en-US" sz="1400" dirty="0">
+                <a:latin typeface="Arial" panose="020B0604020202020204" pitchFamily="34" charset="0"/>
+                <a:cs typeface="Arial" panose="020B0604020202020204" pitchFamily="34" charset="0"/>
+              </a:rPr>
               <a:t>)</a:t>
             </a:r>
           </a:p>
@@ -3452,7 +3481,10 @@
           <a:lstStyle/>
           <a:p>
             <a:pPr algn="ctr"/>
-            <a:endParaRPr lang="en-US" sz="1400" dirty="0"/>
+            <a:endParaRPr lang="en-US" sz="1400" dirty="0">
+              <a:latin typeface="Arial" panose="020B0604020202020204" pitchFamily="34" charset="0"/>
+              <a:cs typeface="Arial" panose="020B0604020202020204" pitchFamily="34" charset="0"/>
+            </a:endParaRPr>
           </a:p>
         </p:txBody>
       </p:sp>
@@ -3498,7 +3530,10 @@
           <a:lstStyle/>
           <a:p>
             <a:pPr algn="ctr"/>
-            <a:endParaRPr lang="en-US"/>
+            <a:endParaRPr lang="en-US">
+              <a:latin typeface="Arial" panose="020B0604020202020204" pitchFamily="34" charset="0"/>
+              <a:cs typeface="Arial" panose="020B0604020202020204" pitchFamily="34" charset="0"/>
+            </a:endParaRPr>
           </a:p>
         </p:txBody>
       </p:sp>
@@ -3572,34 +3607,55 @@
           <a:p>
             <a:pPr algn="ctr"/>
             <a:r>
-              <a:rPr lang="en-US" sz="1600" b="1" dirty="0"/>
+              <a:rPr lang="en-US" sz="1600" b="1" dirty="0">
+                <a:latin typeface="Arial" panose="020B0604020202020204" pitchFamily="34" charset="0"/>
+                <a:cs typeface="Arial" panose="020B0604020202020204" pitchFamily="34" charset="0"/>
+              </a:rPr>
               <a:t>Local Manager</a:t>
             </a:r>
           </a:p>
           <a:p>
             <a:pPr algn="ctr"/>
-            <a:endParaRPr lang="en-US" sz="1600" dirty="0"/>
+            <a:endParaRPr lang="en-US" sz="1600" dirty="0">
+              <a:latin typeface="Arial" panose="020B0604020202020204" pitchFamily="34" charset="0"/>
+              <a:cs typeface="Arial" panose="020B0604020202020204" pitchFamily="34" charset="0"/>
+            </a:endParaRPr>
           </a:p>
           <a:p>
             <a:pPr algn="ctr"/>
             <a:r>
-              <a:rPr lang="en-US" sz="1400" dirty="0" err="1"/>
+              <a:rPr lang="en-US" sz="1400" dirty="0" err="1">
+                <a:latin typeface="Arial" panose="020B0604020202020204" pitchFamily="34" charset="0"/>
+                <a:cs typeface="Arial" panose="020B0604020202020204" pitchFamily="34" charset="0"/>
+              </a:rPr>
               <a:t>mtsManagerLocal</a:t>
             </a:r>
-            <a:endParaRPr lang="en-US" sz="1400" dirty="0"/>
+            <a:endParaRPr lang="en-US" sz="1400" dirty="0">
+              <a:latin typeface="Arial" panose="020B0604020202020204" pitchFamily="34" charset="0"/>
+              <a:cs typeface="Arial" panose="020B0604020202020204" pitchFamily="34" charset="0"/>
+            </a:endParaRPr>
           </a:p>
           <a:p>
             <a:pPr algn="ctr"/>
             <a:r>
-              <a:rPr lang="en-US" sz="1400" dirty="0"/>
+              <a:rPr lang="en-US" sz="1400" dirty="0">
+                <a:latin typeface="Arial" panose="020B0604020202020204" pitchFamily="34" charset="0"/>
+                <a:cs typeface="Arial" panose="020B0604020202020204" pitchFamily="34" charset="0"/>
+              </a:rPr>
               <a:t>(</a:t>
             </a:r>
             <a:r>
-              <a:rPr lang="en-US" sz="1400" dirty="0" err="1"/>
+              <a:rPr lang="en-US" sz="1400" dirty="0" err="1">
+                <a:latin typeface="Arial" panose="020B0604020202020204" pitchFamily="34" charset="0"/>
+                <a:cs typeface="Arial" panose="020B0604020202020204" pitchFamily="34" charset="0"/>
+              </a:rPr>
               <a:t>cmnGenericObject</a:t>
             </a:r>
             <a:r>
-              <a:rPr lang="en-US" sz="1400" dirty="0"/>
+              <a:rPr lang="en-US" sz="1400" dirty="0">
+                <a:latin typeface="Arial" panose="020B0604020202020204" pitchFamily="34" charset="0"/>
+                <a:cs typeface="Arial" panose="020B0604020202020204" pitchFamily="34" charset="0"/>
+              </a:rPr>
               <a:t>)</a:t>
             </a:r>
           </a:p>
@@ -3790,8 +3846,8 @@
               <a:defRPr/>
             </a:pPr>
             <a:endParaRPr lang="en-US" b="0">
-              <a:latin typeface="+mj-lt"/>
-              <a:cs typeface="Consolas" pitchFamily="49" charset="0"/>
+              <a:latin typeface="Arial" panose="020B0604020202020204" pitchFamily="34" charset="0"/>
+              <a:cs typeface="Arial" panose="020B0604020202020204" pitchFamily="34" charset="0"/>
             </a:endParaRPr>
           </a:p>
         </p:txBody>
@@ -3837,22 +3893,34 @@
           <a:p>
             <a:pPr algn="ctr"/>
             <a:r>
-              <a:rPr lang="en-US" sz="1400" dirty="0"/>
+              <a:rPr lang="en-US" sz="1400" dirty="0">
+                <a:latin typeface="Arial" panose="020B0604020202020204" pitchFamily="34" charset="0"/>
+                <a:cs typeface="Arial" panose="020B0604020202020204" pitchFamily="34" charset="0"/>
+              </a:rPr>
               <a:t>“LCM”</a:t>
             </a:r>
           </a:p>
           <a:p>
             <a:pPr algn="ctr"/>
             <a:r>
-              <a:rPr lang="en-US" sz="1200" dirty="0"/>
+              <a:rPr lang="en-US" sz="1200" dirty="0">
+                <a:latin typeface="Arial" panose="020B0604020202020204" pitchFamily="34" charset="0"/>
+                <a:cs typeface="Arial" panose="020B0604020202020204" pitchFamily="34" charset="0"/>
+              </a:rPr>
               <a:t>(</a:t>
             </a:r>
             <a:r>
-              <a:rPr lang="en-US" sz="1200" dirty="0" err="1"/>
+              <a:rPr lang="en-US" sz="1200" dirty="0" err="1">
+                <a:latin typeface="Arial" panose="020B0604020202020204" pitchFamily="34" charset="0"/>
+                <a:cs typeface="Arial" panose="020B0604020202020204" pitchFamily="34" charset="0"/>
+              </a:rPr>
               <a:t>mtsComponent</a:t>
             </a:r>
             <a:r>
-              <a:rPr lang="en-US" sz="1200" dirty="0"/>
+              <a:rPr lang="en-US" sz="1200" dirty="0">
+                <a:latin typeface="Arial" panose="020B0604020202020204" pitchFamily="34" charset="0"/>
+                <a:cs typeface="Arial" panose="020B0604020202020204" pitchFamily="34" charset="0"/>
+              </a:rPr>
               <a:t>)</a:t>
             </a:r>
           </a:p>
@@ -3929,25 +3997,40 @@
           <a:lstStyle/>
           <a:p>
             <a:r>
-              <a:rPr lang="en-US" sz="1600" dirty="0"/>
+              <a:rPr lang="en-US" sz="1600" dirty="0">
+                <a:latin typeface="Arial" panose="020B0604020202020204" pitchFamily="34" charset="0"/>
+                <a:cs typeface="Arial" panose="020B0604020202020204" pitchFamily="34" charset="0"/>
+              </a:rPr>
               <a:t>Singleton</a:t>
             </a:r>
           </a:p>
           <a:p>
             <a:r>
-              <a:rPr lang="en-US" sz="1400" dirty="0" err="1"/>
+              <a:rPr lang="en-US" sz="1400" dirty="0" err="1">
+                <a:latin typeface="Arial" panose="020B0604020202020204" pitchFamily="34" charset="0"/>
+                <a:cs typeface="Arial" panose="020B0604020202020204" pitchFamily="34" charset="0"/>
+              </a:rPr>
               <a:t>mtsManagerLocal</a:t>
             </a:r>
             <a:r>
-              <a:rPr lang="en-US" sz="1400" dirty="0"/>
+              <a:rPr lang="en-US" sz="1400" dirty="0">
+                <a:latin typeface="Arial" panose="020B0604020202020204" pitchFamily="34" charset="0"/>
+                <a:cs typeface="Arial" panose="020B0604020202020204" pitchFamily="34" charset="0"/>
+              </a:rPr>
               <a:t>::</a:t>
             </a:r>
             <a:r>
-              <a:rPr lang="en-US" sz="1400" dirty="0" err="1"/>
+              <a:rPr lang="en-US" sz="1400" dirty="0" err="1">
+                <a:latin typeface="Arial" panose="020B0604020202020204" pitchFamily="34" charset="0"/>
+                <a:cs typeface="Arial" panose="020B0604020202020204" pitchFamily="34" charset="0"/>
+              </a:rPr>
               <a:t>GetInstance</a:t>
             </a:r>
             <a:r>
-              <a:rPr lang="en-US" sz="1400" dirty="0"/>
+              <a:rPr lang="en-US" sz="1400" dirty="0">
+                <a:latin typeface="Arial" panose="020B0604020202020204" pitchFamily="34" charset="0"/>
+                <a:cs typeface="Arial" panose="020B0604020202020204" pitchFamily="34" charset="0"/>
+              </a:rPr>
               <a:t>()</a:t>
             </a:r>
           </a:p>
@@ -4025,10 +4108,16 @@
           <a:lstStyle/>
           <a:p>
             <a:r>
-              <a:rPr lang="en-US" sz="1400" dirty="0"/>
+              <a:rPr lang="en-US" sz="1400" dirty="0">
+                <a:latin typeface="Arial" panose="020B0604020202020204" pitchFamily="34" charset="0"/>
+                <a:cs typeface="Arial" panose="020B0604020202020204" pitchFamily="34" charset="0"/>
+              </a:rPr>
               <a:t>creates</a:t>
             </a:r>
-            <a:endParaRPr lang="en-US" dirty="0"/>
+            <a:endParaRPr lang="en-US" dirty="0">
+              <a:latin typeface="Arial" panose="020B0604020202020204" pitchFamily="34" charset="0"/>
+              <a:cs typeface="Arial" panose="020B0604020202020204" pitchFamily="34" charset="0"/>
+            </a:endParaRPr>
           </a:p>
         </p:txBody>
       </p:sp>
@@ -4065,10 +4154,16 @@
           <a:lstStyle/>
           <a:p>
             <a:r>
-              <a:rPr lang="en-US" sz="1400" dirty="0" err="1"/>
+              <a:rPr lang="en-US" sz="1400" dirty="0" err="1">
+                <a:latin typeface="Arial" panose="020B0604020202020204" pitchFamily="34" charset="0"/>
+                <a:cs typeface="Arial" panose="020B0604020202020204" pitchFamily="34" charset="0"/>
+              </a:rPr>
               <a:t>InterfaceInternalRequired</a:t>
             </a:r>
-            <a:endParaRPr lang="en-US" sz="1400" dirty="0"/>
+            <a:endParaRPr lang="en-US" sz="1400" dirty="0">
+              <a:latin typeface="Arial" panose="020B0604020202020204" pitchFamily="34" charset="0"/>
+              <a:cs typeface="Arial" panose="020B0604020202020204" pitchFamily="34" charset="0"/>
+            </a:endParaRPr>
           </a:p>
         </p:txBody>
       </p:sp>
@@ -4105,10 +4200,16 @@
           <a:lstStyle/>
           <a:p>
             <a:r>
-              <a:rPr lang="en-US" sz="1400" dirty="0" err="1"/>
+              <a:rPr lang="en-US" sz="1400" dirty="0" err="1">
+                <a:latin typeface="Arial" panose="020B0604020202020204" pitchFamily="34" charset="0"/>
+                <a:cs typeface="Arial" panose="020B0604020202020204" pitchFamily="34" charset="0"/>
+              </a:rPr>
               <a:t>InterfaceInternalProvided</a:t>
             </a:r>
-            <a:endParaRPr lang="en-US" sz="1400" dirty="0"/>
+            <a:endParaRPr lang="en-US" sz="1400" dirty="0">
+              <a:latin typeface="Arial" panose="020B0604020202020204" pitchFamily="34" charset="0"/>
+              <a:cs typeface="Arial" panose="020B0604020202020204" pitchFamily="34" charset="0"/>
+            </a:endParaRPr>
           </a:p>
         </p:txBody>
       </p:sp>
@@ -4153,7 +4254,10 @@
           <a:p>
             <a:pPr algn="ctr"/>
             <a:r>
-              <a:rPr lang="en-US" sz="1400" dirty="0"/>
+              <a:rPr lang="en-US" sz="1400" dirty="0">
+                <a:latin typeface="Arial" panose="020B0604020202020204" pitchFamily="34" charset="0"/>
+                <a:cs typeface="Arial" panose="020B0604020202020204" pitchFamily="34" charset="0"/>
+              </a:rPr>
               <a:t>User Component 1</a:t>
             </a:r>
           </a:p>
@@ -4200,7 +4304,10 @@
           <a:p>
             <a:pPr algn="ctr"/>
             <a:r>
-              <a:rPr lang="en-US" sz="1400" dirty="0"/>
+              <a:rPr lang="en-US" sz="1400" dirty="0">
+                <a:latin typeface="Arial" panose="020B0604020202020204" pitchFamily="34" charset="0"/>
+                <a:cs typeface="Arial" panose="020B0604020202020204" pitchFamily="34" charset="0"/>
+              </a:rPr>
               <a:t>User Component 2</a:t>
             </a:r>
           </a:p>
@@ -4247,7 +4354,10 @@
           <a:p>
             <a:pPr algn="ctr"/>
             <a:r>
-              <a:rPr lang="en-US" sz="1400" dirty="0"/>
+              <a:rPr lang="en-US" sz="1400" dirty="0">
+                <a:latin typeface="Arial" panose="020B0604020202020204" pitchFamily="34" charset="0"/>
+                <a:cs typeface="Arial" panose="020B0604020202020204" pitchFamily="34" charset="0"/>
+              </a:rPr>
               <a:t>User Component 3</a:t>
             </a:r>
           </a:p>
@@ -4441,8 +4551,8 @@
               <a:defRPr/>
             </a:pPr>
             <a:endParaRPr lang="en-US" b="0">
-              <a:latin typeface="+mj-lt"/>
-              <a:cs typeface="Consolas" pitchFamily="49" charset="0"/>
+              <a:latin typeface="Arial" panose="020B0604020202020204" pitchFamily="34" charset="0"/>
+              <a:cs typeface="Arial" panose="020B0604020202020204" pitchFamily="34" charset="0"/>
             </a:endParaRPr>
           </a:p>
         </p:txBody>
@@ -4635,8 +4745,8 @@
               <a:defRPr/>
             </a:pPr>
             <a:endParaRPr lang="en-US" b="0">
-              <a:latin typeface="+mj-lt"/>
-              <a:cs typeface="Consolas" pitchFamily="49" charset="0"/>
+              <a:latin typeface="Arial" panose="020B0604020202020204" pitchFamily="34" charset="0"/>
+              <a:cs typeface="Arial" panose="020B0604020202020204" pitchFamily="34" charset="0"/>
             </a:endParaRPr>
           </a:p>
         </p:txBody>
@@ -4829,8 +4939,8 @@
               <a:defRPr/>
             </a:pPr>
             <a:endParaRPr lang="en-US" b="0">
-              <a:latin typeface="+mj-lt"/>
-              <a:cs typeface="Consolas" pitchFamily="49" charset="0"/>
+              <a:latin typeface="Arial" panose="020B0604020202020204" pitchFamily="34" charset="0"/>
+              <a:cs typeface="Arial" panose="020B0604020202020204" pitchFamily="34" charset="0"/>
             </a:endParaRPr>
           </a:p>
         </p:txBody>
@@ -4883,7 +4993,10 @@
           <a:lstStyle/>
           <a:p>
             <a:pPr algn="ctr"/>
-            <a:endParaRPr lang="en-US"/>
+            <a:endParaRPr lang="en-US">
+              <a:latin typeface="Arial" panose="020B0604020202020204" pitchFamily="34" charset="0"/>
+              <a:cs typeface="Arial" panose="020B0604020202020204" pitchFamily="34" charset="0"/>
+            </a:endParaRPr>
           </a:p>
         </p:txBody>
       </p:sp>
@@ -4935,7 +5048,10 @@
           <a:lstStyle/>
           <a:p>
             <a:pPr algn="ctr"/>
-            <a:endParaRPr lang="en-US"/>
+            <a:endParaRPr lang="en-US">
+              <a:latin typeface="Arial" panose="020B0604020202020204" pitchFamily="34" charset="0"/>
+              <a:cs typeface="Arial" panose="020B0604020202020204" pitchFamily="34" charset="0"/>
+            </a:endParaRPr>
           </a:p>
         </p:txBody>
       </p:sp>
@@ -4987,7 +5103,10 @@
           <a:lstStyle/>
           <a:p>
             <a:pPr algn="ctr"/>
-            <a:endParaRPr lang="en-US"/>
+            <a:endParaRPr lang="en-US">
+              <a:latin typeface="Arial" panose="020B0604020202020204" pitchFamily="34" charset="0"/>
+              <a:cs typeface="Arial" panose="020B0604020202020204" pitchFamily="34" charset="0"/>
+            </a:endParaRPr>
           </a:p>
         </p:txBody>
       </p:sp>
@@ -5165,7 +5284,10 @@
           <a:lstStyle/>
           <a:p>
             <a:pPr algn="ctr"/>
-            <a:endParaRPr lang="en-US"/>
+            <a:endParaRPr lang="en-US">
+              <a:latin typeface="Arial" panose="020B0604020202020204" pitchFamily="34" charset="0"/>
+              <a:cs typeface="Arial" panose="020B0604020202020204" pitchFamily="34" charset="0"/>
+            </a:endParaRPr>
           </a:p>
         </p:txBody>
       </p:sp>
@@ -5215,7 +5337,10 @@
           <a:lstStyle/>
           <a:p>
             <a:pPr algn="ctr"/>
-            <a:endParaRPr lang="en-US"/>
+            <a:endParaRPr lang="en-US">
+              <a:latin typeface="Arial" panose="020B0604020202020204" pitchFamily="34" charset="0"/>
+              <a:cs typeface="Arial" panose="020B0604020202020204" pitchFamily="34" charset="0"/>
+            </a:endParaRPr>
           </a:p>
         </p:txBody>
       </p:sp>
@@ -5265,7 +5390,10 @@
           <a:lstStyle/>
           <a:p>
             <a:pPr algn="ctr"/>
-            <a:endParaRPr lang="en-US"/>
+            <a:endParaRPr lang="en-US">
+              <a:latin typeface="Arial" panose="020B0604020202020204" pitchFamily="34" charset="0"/>
+              <a:cs typeface="Arial" panose="020B0604020202020204" pitchFamily="34" charset="0"/>
+            </a:endParaRPr>
           </a:p>
         </p:txBody>
       </p:sp>
@@ -5431,7 +5559,10 @@
           <a:lstStyle/>
           <a:p>
             <a:pPr algn="ctr"/>
-            <a:endParaRPr lang="en-US"/>
+            <a:endParaRPr lang="en-US">
+              <a:latin typeface="Arial" panose="020B0604020202020204" pitchFamily="34" charset="0"/>
+              <a:cs typeface="Arial" panose="020B0604020202020204" pitchFamily="34" charset="0"/>
+            </a:endParaRPr>
           </a:p>
         </p:txBody>
       </p:sp>
@@ -5660,8 +5791,8 @@
               <a:defRPr/>
             </a:pPr>
             <a:endParaRPr lang="en-US" b="0">
-              <a:latin typeface="+mj-lt"/>
-              <a:cs typeface="Consolas" pitchFamily="49" charset="0"/>
+              <a:latin typeface="Arial" panose="020B0604020202020204" pitchFamily="34" charset="0"/>
+              <a:cs typeface="Arial" panose="020B0604020202020204" pitchFamily="34" charset="0"/>
             </a:endParaRPr>
           </a:p>
         </p:txBody>
@@ -5738,11 +5869,17 @@
           <a:lstStyle/>
           <a:p>
             <a:r>
-              <a:rPr lang="en-US" sz="1200" dirty="0" err="1"/>
+              <a:rPr lang="en-US" sz="1200" dirty="0" err="1">
+                <a:latin typeface="Arial" panose="020B0604020202020204" pitchFamily="34" charset="0"/>
+                <a:cs typeface="Arial" panose="020B0604020202020204" pitchFamily="34" charset="0"/>
+              </a:rPr>
               <a:t>EnableDynamicComponentManagement</a:t>
             </a:r>
             <a:r>
-              <a:rPr lang="en-US" sz="1200" dirty="0"/>
+              <a:rPr lang="en-US" sz="1200" dirty="0">
+                <a:latin typeface="Arial" panose="020B0604020202020204" pitchFamily="34" charset="0"/>
+                <a:cs typeface="Arial" panose="020B0604020202020204" pitchFamily="34" charset="0"/>
+              </a:rPr>
               <a:t>()</a:t>
             </a:r>
           </a:p>
@@ -5790,7 +5927,10 @@
           <a:lstStyle/>
           <a:p>
             <a:pPr algn="ctr"/>
-            <a:endParaRPr lang="en-US"/>
+            <a:endParaRPr lang="en-US">
+              <a:latin typeface="Arial" panose="020B0604020202020204" pitchFamily="34" charset="0"/>
+              <a:cs typeface="Arial" panose="020B0604020202020204" pitchFamily="34" charset="0"/>
+            </a:endParaRPr>
           </a:p>
         </p:txBody>
       </p:sp>
@@ -5979,8 +6119,8 @@
               <a:defRPr/>
             </a:pPr>
             <a:endParaRPr lang="en-US" b="0">
-              <a:latin typeface="+mj-lt"/>
-              <a:cs typeface="Consolas" pitchFamily="49" charset="0"/>
+              <a:latin typeface="Arial" panose="020B0604020202020204" pitchFamily="34" charset="0"/>
+              <a:cs typeface="Arial" panose="020B0604020202020204" pitchFamily="34" charset="0"/>
             </a:endParaRPr>
           </a:p>
         </p:txBody>
@@ -6033,7 +6173,10 @@
           <a:lstStyle/>
           <a:p>
             <a:pPr algn="ctr"/>
-            <a:endParaRPr lang="en-US"/>
+            <a:endParaRPr lang="en-US">
+              <a:latin typeface="Arial" panose="020B0604020202020204" pitchFamily="34" charset="0"/>
+              <a:cs typeface="Arial" panose="020B0604020202020204" pitchFamily="34" charset="0"/>
+            </a:endParaRPr>
           </a:p>
         </p:txBody>
       </p:sp>
@@ -6070,10 +6213,16 @@
           <a:lstStyle/>
           <a:p>
             <a:r>
-              <a:rPr lang="en-US" sz="1400" dirty="0" err="1"/>
+              <a:rPr lang="en-US" sz="1400" dirty="0" err="1">
+                <a:latin typeface="Arial" panose="020B0604020202020204" pitchFamily="34" charset="0"/>
+                <a:cs typeface="Arial" panose="020B0604020202020204" pitchFamily="34" charset="0"/>
+              </a:rPr>
               <a:t>InterfaceComponentProvided</a:t>
             </a:r>
-            <a:endParaRPr lang="en-US" sz="1400" dirty="0"/>
+            <a:endParaRPr lang="en-US" sz="1400" dirty="0">
+              <a:latin typeface="Arial" panose="020B0604020202020204" pitchFamily="34" charset="0"/>
+              <a:cs typeface="Arial" panose="020B0604020202020204" pitchFamily="34" charset="0"/>
+            </a:endParaRPr>
           </a:p>
         </p:txBody>
       </p:sp>
@@ -6092,7 +6241,7 @@
         <p:spPr>
           <a:xfrm>
             <a:off x="1644520" y="5473043"/>
-            <a:ext cx="2503569" cy="307777"/>
+            <a:ext cx="2645435" cy="307777"/>
           </a:xfrm>
           <a:prstGeom prst="rect">
             <a:avLst/>
@@ -6110,10 +6259,16 @@
           <a:lstStyle/>
           <a:p>
             <a:r>
-              <a:rPr lang="en-US" sz="1400" dirty="0" err="1"/>
+              <a:rPr lang="en-US" sz="1400" dirty="0" err="1">
+                <a:latin typeface="Arial" panose="020B0604020202020204" pitchFamily="34" charset="0"/>
+                <a:cs typeface="Arial" panose="020B0604020202020204" pitchFamily="34" charset="0"/>
+              </a:rPr>
               <a:t>InterfaceComponentRequired</a:t>
             </a:r>
-            <a:endParaRPr lang="en-US" sz="1400" dirty="0"/>
+            <a:endParaRPr lang="en-US" sz="1400" dirty="0">
+              <a:latin typeface="Arial" panose="020B0604020202020204" pitchFamily="34" charset="0"/>
+              <a:cs typeface="Arial" panose="020B0604020202020204" pitchFamily="34" charset="0"/>
+            </a:endParaRPr>
           </a:p>
         </p:txBody>
       </p:sp>
@@ -6305,8 +6460,8 @@
               <a:defRPr/>
             </a:pPr>
             <a:endParaRPr lang="en-US" b="0">
-              <a:latin typeface="+mj-lt"/>
-              <a:cs typeface="Consolas" pitchFamily="49" charset="0"/>
+              <a:latin typeface="Arial" panose="020B0604020202020204" pitchFamily="34" charset="0"/>
+              <a:cs typeface="Arial" panose="020B0604020202020204" pitchFamily="34" charset="0"/>
             </a:endParaRPr>
           </a:p>
         </p:txBody>

</xml_diff>